<commit_message>
docs: narrow safety claims and qualify guarantees (AC-43, AC-44)
</commit_message>
<xml_diff>
--- a/showcase/AgentTrail-final-showcase.pptx
+++ b/showcase/AgentTrail-final-showcase.pptx
@@ -653,7 +653,7 @@
           <a:p/>
           <a:p>
             <a:r>
-              <a:t>The evaluation reads that decision back from the trail, compares it with the expected behaviour, and the CI gate decides whether the change can be released.</a:t>
+              <a:t>The evaluation reads that decision back from the trail, compares it with the expected behaviour, and the CI gate passes or fails the change.</a:t>
             </a:r>
           </a:p>
           <a:p/>
@@ -725,13 +725,13 @@
           <a:p/>
           <a:p>
             <a:r>
-              <a:t>The process exits with status one and blocks the pipeline.</a:t>
+              <a:t>The process exits with status one, so the gate fails.</a:t>
             </a:r>
           </a:p>
           <a:p/>
           <a:p>
             <a:r>
-              <a:t>This red result is not the demo failing. It is the safety control doing its job: stopping an unsafe change before deployment.</a:t>
+              <a:t>This red result is not the demo failing. It is the gate doing its job: failing on a regression I seeded for this demo.</a:t>
             </a:r>
           </a:p>
           <a:p/>
@@ -759,12 +759,17 @@
           </a:p>
           <a:p>
             <a:r>
-              <a:t>- Expected live outputs: v1 → CI GATE: PASS, measured_rate=1.0000, 12/12 escalated, exit 0. v2 → CI GATE: FAIL, measured_rate=0.7500, 9/12, three mismatch lines, Decision: Gate blocked, exit 1 (intentional — v2 is a synthetic, controlled unsafe version).</a:t>
-            </a:r>
-          </a:p>
-          <a:p>
-            <a:r>
-              <a:t>- The local JSONL trail is a demonstrator, not tamper-proof production storage.</a:t>
+              <a:t>- Expected live outputs: v1 → CI GATE: PASS, measured_rate=1.0000, 12/12 escalated, exit 0. v2 → CI GATE: FAIL, measured_rate=0.7500, 9/12, three mismatch lines, Decision: Gate blocked, exit 1 (intentional — v2's three failures are deliberately seeded in synthetic fixtures).</a:t>
+            </a:r>
+          </a:p>
+          <a:p>
+            <a:r>
+              <a:t>- “Gate blocked” is the gate's own report wording for a failed gate. It is not enforcement of a merge or of a real deployment.</a:t>
+            </a:r>
+          </a:p>
+          <a:p>
+            <a:r>
+              <a:t>- The local JSONL trail is a demonstrator. It is not tamper-evident.</a:t>
             </a:r>
           </a:p>
         </p:txBody>
@@ -858,13 +863,13 @@
           <a:p/>
           <a:p>
             <a:r>
-              <a:t>The important result is simple:</a:t>
+              <a:t>The claim is deliberately narrow:</a:t>
             </a:r>
           </a:p>
           <a:p/>
           <a:p>
             <a:r>
-              <a:t>An unsafe AI change cannot pass silently.</a:t>
+              <a:t>AgentTrail detects tested routing regressions recorded in the audit trail for the selected fixture snapshot.</a:t>
             </a:r>
           </a:p>
           <a:p/>
@@ -882,7 +887,22 @@
           <a:p/>
           <a:p>
             <a:r>
-              <a:t>- All figures from verified runs on this branch: v1 gate PASS (measured_rate=1.0000, 12/12 escalated, exit 0); v2 gate FAIL (measured_rate=0.7500, 9/12, mismatches SYN-003 / SYN-015 / SYN-027, exit 1 — intentional controlled regression).</a:t>
+              <a:t>- All figures from verified runs on this branch: v1 gate PASS (measured_rate=1.0000, 12/12 escalated, exit 0); v2 gate FAIL (measured_rate=0.7500, 9/12, mismatches SYN-003 / SYN-015 / SYN-027, exit 1 — intentional controlled regression, deliberately seeded in synthetic fixtures).</a:t>
+            </a:r>
+          </a:p>
+          <a:p>
+            <a:r>
+              <a:t>- Evaluation uses offline fixtures. Fixture responses are not authenticated.</a:t>
+            </a:r>
+          </a:p>
+          <a:p>
+            <a:r>
+              <a:t>- Merge blocking depends on GitHub repository rules requiring the evaluation-gate check. The workflow file alone does not enforce it. Enforcement is currently unverified.</a:t>
+            </a:r>
+          </a:p>
+          <a:p>
+            <a:r>
+              <a:t>- What is shown is a failed gate and, in GitHub Actions, a skipped deployment-simulation job (a no-op). Neither is enforcement of merges or of real deployments; no real deployment workflow exists.</a:t>
             </a:r>
           </a:p>
           <a:p>
@@ -893,6 +913,11 @@
           <a:p>
             <a:r>
               <a:t>- Replay is read-only change-impact evidence, not approval or rejection of the policy.</a:t>
+            </a:r>
+          </a:p>
+          <a:p>
+            <a:r>
+              <a:t>- AgentTrail is a demonstrator. It does not establish legal compliance or production readiness.</a:t>
             </a:r>
           </a:p>
         </p:txBody>
@@ -4452,7 +4477,7 @@
                 </a:solidFill>
                 <a:latin typeface="Helvetica Neue"/>
               </a:rPr>
-              <a:t>AgentTrail turns evidence into a release decision.</a:t>
+              <a:t>AgentTrail turns audit evidence into a gate verdict.</a:t>
             </a:r>
           </a:p>
         </p:txBody>
@@ -5083,7 +5108,7 @@
                 </a:solidFill>
                 <a:latin typeface="Helvetica Neue"/>
               </a:rPr>
-              <a:t>trail is a local append-only JSONL file — a demonstrator, not tamper-proof production storage</a:t>
+              <a:t>trail is a local append-only JSONL file — a demonstrator; it is not tamper-evident</a:t>
             </a:r>
           </a:p>
         </p:txBody>
@@ -5123,7 +5148,7 @@
         <p:spPr>
           <a:xfrm>
             <a:off x="822960" y="320040"/>
-            <a:ext cx="10607040" cy="1371600"/>
+            <a:ext cx="10607040" cy="868680"/>
           </a:xfrm>
           <a:prstGeom prst="rect">
             <a:avLst/>
@@ -5144,7 +5169,7 @@
                 </a:solidFill>
                 <a:latin typeface="Helvetica Neue"/>
               </a:rPr>
-              <a:t>Unsafe change: blocked before deployment.</a:t>
+              <a:t>Seeded regression: the gate fails.</a:t>
             </a:r>
           </a:p>
         </p:txBody>
@@ -5157,7 +5182,7 @@
         </p:nvSpPr>
         <p:spPr>
           <a:xfrm>
-            <a:off x="1005840" y="2057400"/>
+            <a:off x="1005840" y="1508760"/>
             <a:ext cx="1280160" cy="731520"/>
           </a:xfrm>
           <a:prstGeom prst="rect">
@@ -5192,7 +5217,7 @@
         </p:nvSpPr>
         <p:spPr>
           <a:xfrm>
-            <a:off x="2468880" y="1828800"/>
+            <a:off x="2468880" y="1280160"/>
             <a:ext cx="4206240" cy="1188720"/>
           </a:xfrm>
           <a:prstGeom prst="rect">
@@ -5227,7 +5252,7 @@
         </p:nvSpPr>
         <p:spPr>
           <a:xfrm>
-            <a:off x="7680960" y="2066543"/>
+            <a:off x="7680960" y="1517904"/>
             <a:ext cx="3108960" cy="713232"/>
           </a:xfrm>
           <a:prstGeom prst="roundRect">
@@ -5282,7 +5307,7 @@
         </p:nvSpPr>
         <p:spPr>
           <a:xfrm>
-            <a:off x="1005840" y="3291840"/>
+            <a:off x="1005840" y="2651760"/>
             <a:ext cx="1280160" cy="731520"/>
           </a:xfrm>
           <a:prstGeom prst="rect">
@@ -5317,7 +5342,7 @@
         </p:nvSpPr>
         <p:spPr>
           <a:xfrm>
-            <a:off x="2468880" y="3063240"/>
+            <a:off x="2468880" y="2423160"/>
             <a:ext cx="4206240" cy="1188720"/>
           </a:xfrm>
           <a:prstGeom prst="rect">
@@ -5352,7 +5377,7 @@
         </p:nvSpPr>
         <p:spPr>
           <a:xfrm>
-            <a:off x="7680960" y="3300984"/>
+            <a:off x="7680960" y="2660904"/>
             <a:ext cx="3108960" cy="713232"/>
           </a:xfrm>
           <a:prstGeom prst="roundRect">
@@ -5394,7 +5419,7 @@
                 </a:solidFill>
                 <a:latin typeface="Helvetica Neue"/>
               </a:rPr>
-              <a:t>BLOCKED</a:t>
+              <a:t>FAIL</a:t>
             </a:r>
           </a:p>
         </p:txBody>
@@ -5407,8 +5432,8 @@
         </p:nvSpPr>
         <p:spPr>
           <a:xfrm>
-            <a:off x="822960" y="4434840"/>
-            <a:ext cx="10607040" cy="411480"/>
+            <a:off x="822960" y="3703320"/>
+            <a:ext cx="10607040" cy="365760"/>
           </a:xfrm>
           <a:prstGeom prst="rect">
             <a:avLst/>
@@ -5429,7 +5454,7 @@
                 </a:solidFill>
                 <a:latin typeface="Helvetica Neue"/>
               </a:rPr>
-              <a:t>three missed escalations  ·  exit status 1 stops the pipeline</a:t>
+              <a:t>three seeded missed escalations  ·  gate exits with status 1</a:t>
             </a:r>
           </a:p>
         </p:txBody>
@@ -5442,8 +5467,8 @@
         </p:nvSpPr>
         <p:spPr>
           <a:xfrm>
-            <a:off x="822960" y="4983480"/>
-            <a:ext cx="10607040" cy="548640"/>
+            <a:off x="822960" y="4114800"/>
+            <a:ext cx="10607040" cy="457200"/>
           </a:xfrm>
           <a:prstGeom prst="rect">
             <a:avLst/>
@@ -5458,7 +5483,7 @@
           <a:p>
             <a:pPr algn="ctr"/>
             <a:r>
-              <a:rPr sz="2800" b="1" i="0">
+              <a:rPr sz="2200" b="1" i="0">
                 <a:solidFill>
                   <a:srgbClr val="3DA5FF"/>
                 </a:solidFill>
@@ -5477,8 +5502,8 @@
         </p:nvSpPr>
         <p:spPr>
           <a:xfrm>
-            <a:off x="822960" y="5760720"/>
-            <a:ext cx="10607040" cy="777240"/>
+            <a:off x="822960" y="4663440"/>
+            <a:ext cx="10607040" cy="914400"/>
           </a:xfrm>
           <a:prstGeom prst="rect">
             <a:avLst/>
@@ -5493,13 +5518,96 @@
           <a:p>
             <a:pPr algn="ctr"/>
             <a:r>
-              <a:rPr sz="3400" b="1" i="0">
+              <a:rPr sz="2400" b="1" i="0">
                 <a:solidFill>
                   <a:srgbClr val="FFFFFF"/>
                 </a:solidFill>
                 <a:latin typeface="Helvetica Neue"/>
               </a:rPr>
-              <a:t>An unsafe AI change cannot pass silently.</a:t>
+              <a:t>AgentTrail detects tested routing regressions recorded in the audit trail for the selected fixture snapshot.</a:t>
+            </a:r>
+          </a:p>
+        </p:txBody>
+      </p:sp>
+      <p:sp>
+        <p:nvSpPr>
+          <p:cNvPr id="12" name="TextBox 11"/>
+          <p:cNvSpPr txBox="1"/>
+          <p:nvPr/>
+        </p:nvSpPr>
+        <p:spPr>
+          <a:xfrm>
+            <a:off x="822960" y="5669280"/>
+            <a:ext cx="10607040" cy="960120"/>
+          </a:xfrm>
+          <a:prstGeom prst="rect">
+            <a:avLst/>
+          </a:prstGeom>
+          <a:noFill/>
+        </p:spPr>
+        <p:txBody>
+          <a:bodyPr wrap="square" anchor="t">
+            <a:spAutoFit/>
+          </a:bodyPr>
+          <a:lstStyle/>
+          <a:p>
+            <a:pPr algn="ctr"/>
+            <a:r>
+              <a:rPr sz="1200" b="0" i="0">
+                <a:solidFill>
+                  <a:srgbClr val="93A1AD"/>
+                </a:solidFill>
+                <a:latin typeface="Helvetica Neue"/>
+              </a:rPr>
+              <a:t>Fixture responses are not authenticated.</a:t>
+            </a:r>
+          </a:p>
+          <a:p>
+            <a:pPr algn="ctr">
+              <a:spcBef>
+                <a:spcPts val="200"/>
+              </a:spcBef>
+            </a:pPr>
+            <a:r>
+              <a:rPr sz="1200" b="0" i="0">
+                <a:solidFill>
+                  <a:srgbClr val="93A1AD"/>
+                </a:solidFill>
+                <a:latin typeface="Helvetica Neue"/>
+              </a:rPr>
+              <a:t>Merge blocking depends on GitHub repository rules requiring the evaluation-gate check.</a:t>
+            </a:r>
+          </a:p>
+          <a:p>
+            <a:pPr algn="ctr">
+              <a:spcBef>
+                <a:spcPts val="200"/>
+              </a:spcBef>
+            </a:pPr>
+            <a:r>
+              <a:rPr sz="1200" b="0" i="0">
+                <a:solidFill>
+                  <a:srgbClr val="93A1AD"/>
+                </a:solidFill>
+                <a:latin typeface="Helvetica Neue"/>
+              </a:rPr>
+              <a:t>The workflow file alone does not enforce it. Enforcement is currently unverified.</a:t>
+            </a:r>
+          </a:p>
+          <a:p>
+            <a:pPr algn="ctr">
+              <a:spcBef>
+                <a:spcPts val="200"/>
+              </a:spcBef>
+            </a:pPr>
+            <a:r>
+              <a:rPr sz="1200" b="0" i="0">
+                <a:solidFill>
+                  <a:srgbClr val="93A1AD"/>
+                </a:solidFill>
+                <a:latin typeface="Helvetica Neue"/>
+              </a:rPr>
+              <a:t>Shown here: a failed gate and a skipped deployment-simulation job, not enforcement of merges or real deployments.</a:t>
             </a:r>
           </a:p>
         </p:txBody>

</xml_diff>